<commit_message>
Rolverdeling gecorrigeerd in het planningdeck
De statisticus is eruit; het SAP hoort bij het onderzoeksteam. Op de
septemberdia staat nu de scoping review in die plaats, wat inhoudelijk ook
klopt: die begint met de vraagstelling en niet met lezen.

Koen Putman en Maaike Fobelets dragen de gezondheidseconomische analyse en de
procesevaluatie, allebei. Dat stond verkeerd: de procesevaluatie lag bij
Dobbels.

Fabienne Dobbels draagt SEBIA, en dat stond nergens. Het is nu een eigen
werkstroom: de vijf gespreksmomenten, de scholing in motiverende
gespreksvoering, en de afspraak wanneer de fideliteitschecklist ingevuld wordt.
Dat laatste bepaalt of je bij een nulresultaat kunt zeggen of het mechanisme
faalde of de uitvoering.

Verder een rij ingekort die in het slotvak liep, en de spreektekst van twee
dia's herschreven.

Co-Authored-By: Claude Opus 5 <noreply@anthropic.com>
</commit_message>
<xml_diff>
--- a/PARADISE_presentatie/PARADISE_planning_sep-nov.pptx
+++ b/PARADISE_presentatie/PARADISE_planning_sep-nov.pptx
@@ -1098,7 +1098,7 @@
           </a:p>
           <a:p>
             <a:r>
-              <a:t>De verdeling is scheef en dat hoort ook: voorbereidend werk is coördinatiewerk. Veertig dagen bij mij, vijf à zes bij Kevin, vijf bij de statisticus in oktober, en één dag per centrum. Die laatste is de enige die ik niet zelf in de hand heb.</a:t>
+              <a:t>De verdeling is scheef en dat hoort ook: voorbereidend werk is coördinatiewerk. Veertig dagen bij mij, zes bij Kevin, en één dag per centrum. Koen en Maaike dragen de economische analyse én de procesevaluatie, Fabienne draagt SEBIA. Die drie lopen door tot het einde.</a:t>
             </a:r>
           </a:p>
           <a:p/>
@@ -1670,27 +1670,31 @@
               <a:t>WAT U ZEGT</a:t>
             </a:r>
           </a:p>
+          <a:p>
+            <a:r>
+              <a:t>Vier dingen, en geen ervan kan wachten. Het protocol sluitend maken kost drie dagen, en alles daarna bouwt erop voort. De adjudicatiecommissie vraagt mensen van buiten, dus die vraag gaat vandaag de deur uit. En de scoping review begint met de vraagstelling, niet met lezen.</a:t>
+            </a:r>
+          </a:p>
           <a:p/>
+          <a:p>
+            <a:r>
+              <a:t>PRESENTATIETIP</a:t>
+            </a:r>
+          </a:p>
+          <a:p>
+            <a:r>
+              <a:t>Het protocol is de spil: alles in oktober bouwt erop voort. Vraag de adjudicatieleden vandaag, want mensen van buiten hebben bedenktijd nodig.</a:t>
+            </a:r>
+          </a:p>
           <a:p/>
           <a:p>
             <a:r>
-              <a:t>PRESENTATIETIP</a:t>
-            </a:r>
-          </a:p>
-          <a:p>
-            <a:r>
-              <a:t>De statisticus is de stilste blokkade: zonder aanstelling geen SAP, en het SAP moet vóór de eerste patiënt vastliggen.</a:t>
-            </a:r>
-          </a:p>
-          <a:p/>
-          <a:p>
-            <a:r>
               <a:t>INTERACTIE</a:t>
             </a:r>
           </a:p>
           <a:p>
             <a:r>
-              <a:t>Vraag Kevin ter plekke om een naam.</a:t>
+              <a:t>Vraag wie zij zouden voorstellen voor de adjudicatie.</a:t>
             </a:r>
           </a:p>
         </p:txBody>
@@ -9625,7 +9629,7 @@
                 </a:solidFill>
                 <a:latin typeface="Segoe UI"/>
               </a:rPr>
-              <a:t>Protocol, SOP’s en materiaal</a:t>
+              <a:t>Protocol, SAP en materiaal</a:t>
             </a:r>
           </a:p>
         </p:txBody>
@@ -10040,7 +10044,7 @@
                 </a:solidFill>
                 <a:latin typeface="Segoe UI"/>
               </a:rPr>
-              <a:t>Statisticus aanstellen</a:t>
+              <a:t>Beide commissies werven</a:t>
             </a:r>
           </a:p>
         </p:txBody>
@@ -10123,7 +10127,7 @@
                 </a:solidFill>
                 <a:latin typeface="Segoe UI"/>
               </a:rPr>
-              <a:t>Beide commissies werven</a:t>
+              <a:t>Co-auteurronde</a:t>
             </a:r>
           </a:p>
         </p:txBody>
@@ -10206,7 +10210,7 @@
                 </a:solidFill>
                 <a:latin typeface="Segoe UI"/>
               </a:rPr>
-              <a:t>Statisticus · 5 d</a:t>
+              <a:t>Putman · Fobelets</a:t>
             </a:r>
           </a:p>
         </p:txBody>
@@ -10289,7 +10293,7 @@
                 </a:solidFill>
                 <a:latin typeface="Segoe UI"/>
               </a:rPr>
-              <a:t>SAP schrijven</a:t>
+              <a:t>Gezondheidseconomische analyse</a:t>
             </a:r>
           </a:p>
         </p:txBody>
@@ -10372,7 +10376,7 @@
                 </a:solidFill>
                 <a:latin typeface="Segoe UI"/>
               </a:rPr>
-              <a:t>Zitting stuurgroep</a:t>
+              <a:t>Procesevaluatie</a:t>
             </a:r>
           </a:p>
         </p:txBody>
@@ -10455,7 +10459,7 @@
                 </a:solidFill>
                 <a:latin typeface="Segoe UI"/>
               </a:rPr>
-              <a:t>Blijft geblindeerd</a:t>
+              <a:t>Beide afnameschema’s</a:t>
             </a:r>
           </a:p>
         </p:txBody>
@@ -10538,7 +10542,7 @@
                 </a:solidFill>
                 <a:latin typeface="Segoe UI"/>
               </a:rPr>
-              <a:t>Per centrum · 1 d</a:t>
+              <a:t>Dobbels · SEBIA</a:t>
             </a:r>
           </a:p>
         </p:txBody>
@@ -10621,7 +10625,7 @@
                 </a:solidFill>
                 <a:latin typeface="Segoe UI"/>
               </a:rPr>
-              <a:t>Team samenbrengen</a:t>
+              <a:t>De vijf gespreksmomenten</a:t>
             </a:r>
           </a:p>
         </p:txBody>
@@ -10704,7 +10708,7 @@
                 </a:solidFill>
                 <a:latin typeface="Segoe UI"/>
               </a:rPr>
-              <a:t>Opleiding volgen</a:t>
+              <a:t>Motiverende gespreksvoering</a:t>
             </a:r>
           </a:p>
         </p:txBody>
@@ -10787,7 +10791,7 @@
                 </a:solidFill>
                 <a:latin typeface="Segoe UI"/>
               </a:rPr>
-              <a:t>Droogloop uitvoeren</a:t>
+              <a:t>Fideliteitsafspraken</a:t>
             </a:r>
           </a:p>
         </p:txBody>
@@ -14669,7 +14673,7 @@
                 </a:solidFill>
                 <a:latin typeface="Segoe UI"/>
               </a:rPr>
-              <a:t>Statisticus aanstellen</a:t>
+              <a:t>Scoping review starten</a:t>
             </a:r>
           </a:p>
         </p:txBody>
@@ -14708,7 +14712,7 @@
                 </a:solidFill>
                 <a:latin typeface="Segoe UI"/>
               </a:rPr>
-              <a:t>Zitting in de stuurgroep, geblindeerd tot de primaire analyse, schrijft het SAP. Er staat nergens een naam.</a:t>
+              <a:t>Vraag kiezen en het protocol registreren voor de zoektocht begint. Anders is het een literatuuroverzicht, geen review.</a:t>
             </a:r>
           </a:p>
         </p:txBody>
@@ -14747,7 +14751,7 @@
                 </a:solidFill>
                 <a:latin typeface="Consolas"/>
               </a:rPr>
-              <a:t>1 d</a:t>
+              <a:t>2 d</a:t>
             </a:r>
           </a:p>
         </p:txBody>
@@ -15156,7 +15160,7 @@
                 </a:solidFill>
                 <a:latin typeface="Segoe UI"/>
               </a:rPr>
-              <a:t>En de scoping review starten: vraag kiezen en het protocol registreren vóór de zoektocht begint.</a:t>
+              <a:t>Vier dingen, en geen ervan kan wachten tot oktober: alles wat daarna komt bouwt hierop voort.</a:t>
             </a:r>
           </a:p>
         </p:txBody>
@@ -17055,7 +17059,7 @@
                 </a:solidFill>
                 <a:latin typeface="Segoe UI"/>
               </a:rPr>
-              <a:t>Papier in het centrum of via manGO. Zonder route weten zes centra niet wat ze met een ingevuld formulier moeten.</a:t>
+              <a:t>Papier in het centrum of via manGO. Zonder route weet niemand wat hij met een ingevuld formulier moet.</a:t>
             </a:r>
           </a:p>
         </p:txBody>
@@ -17107,8 +17111,8 @@
         </p:nvSpPr>
         <p:spPr>
           <a:xfrm>
-            <a:off x="634984" y="5371965"/>
-            <a:ext cx="10921726" cy="736581"/>
+            <a:off x="634984" y="4992194"/>
+            <a:ext cx="10921726" cy="1116352"/>
           </a:xfrm>
           <a:prstGeom prst="roundRect">
             <a:avLst>
@@ -17155,8 +17159,8 @@
         </p:nvSpPr>
         <p:spPr>
           <a:xfrm>
-            <a:off x="952476" y="5549761"/>
-            <a:ext cx="10286742" cy="380990"/>
+            <a:off x="952476" y="5169989"/>
+            <a:ext cx="10286742" cy="760761"/>
           </a:xfrm>
           <a:prstGeom prst="rect">
             <a:avLst/>
@@ -17181,7 +17185,7 @@
                 </a:solidFill>
                 <a:latin typeface="Segoe UI"/>
               </a:rPr>
-              <a:t>Plus het materiaalontwerp en de protocolpaper afwerken — samen nog eens acht dagen.</a:t>
+              <a:t>Plus het materiaalontwerp, de protocolpaper, en de afnameschema’s van Koen en Maaike voor de economische analyse en de procesevaluatie.</a:t>
             </a:r>
           </a:p>
         </p:txBody>

</xml_diff>

<commit_message>
Planning lean gemaakt: tabel in plaats van proza
Het artefact stond vol afsluitende wijsheden en tweeledige constructies. Dat
leest als geschreven om te imponeren, niet om uit te voeren. Nu een tabel: week,
taak, wie, resultaat, tijd. Drieentwintig rijen. Van 48,8 naar 18,4 KB en van
ongeveer 2400 naar 755 woorden, zonder dat er een taak verdwijnt.

Bovenaan staat wie wat doet, met de dagen erbij, zodat iedereen zijn eigen naam
kan zoeken en meteen ziet wat van hem verwacht wordt.

De zes foolproof-regels zijn teruggebracht tot een regel elk, met het echte
voorval als bijzin in plaats van als alinea.

In het deck tien slotregels en beschrijvingen ingekort. Het langste slot ging
van twee zinnen met een pointe naar een zin die zegt wat er moet gebeuren.

Co-Authored-By: Claude Opus 5 <noreply@anthropic.com>
</commit_message>
<xml_diff>
--- a/PARADISE_presentatie/PARADISE_planning_sep-nov.pptx
+++ b/PARADISE_presentatie/PARADISE_planning_sep-nov.pptx
@@ -6834,8 +6834,8 @@
         </p:nvSpPr>
         <p:spPr>
           <a:xfrm>
-            <a:off x="634984" y="4992194"/>
-            <a:ext cx="10921726" cy="1116352"/>
+            <a:off x="634984" y="5371965"/>
+            <a:ext cx="10921726" cy="736581"/>
           </a:xfrm>
           <a:prstGeom prst="roundRect">
             <a:avLst>
@@ -6882,8 +6882,8 @@
         </p:nvSpPr>
         <p:spPr>
           <a:xfrm>
-            <a:off x="952476" y="5169989"/>
-            <a:ext cx="10286742" cy="760761"/>
+            <a:off x="952476" y="5549761"/>
+            <a:ext cx="10286742" cy="380990"/>
           </a:xfrm>
           <a:prstGeom prst="rect">
             <a:avLst/>
@@ -6908,7 +6908,7 @@
                 </a:solidFill>
                 <a:latin typeface="Segoe UI"/>
               </a:rPr>
-              <a:t>De droogloop is waar u ontdekt dat het netwerk de uitleessoftware blokkeert, of dat het looppad als opslagruimte gebruikt wordt.</a:t>
+              <a:t>De droogloop legt bloot wat op papier klopte en in de praktijk niet.</a:t>
             </a:r>
           </a:p>
         </p:txBody>
@@ -7899,8 +7899,8 @@
         </p:nvSpPr>
         <p:spPr>
           <a:xfrm>
-            <a:off x="634984" y="4992194"/>
-            <a:ext cx="10921726" cy="1116352"/>
+            <a:off x="634984" y="5371965"/>
+            <a:ext cx="10921726" cy="736581"/>
           </a:xfrm>
           <a:prstGeom prst="roundRect">
             <a:avLst>
@@ -7947,8 +7947,8 @@
         </p:nvSpPr>
         <p:spPr>
           <a:xfrm>
-            <a:off x="952476" y="5169989"/>
-            <a:ext cx="10286742" cy="760761"/>
+            <a:off x="952476" y="5549761"/>
+            <a:ext cx="10286742" cy="380990"/>
           </a:xfrm>
           <a:prstGeom prst="rect">
             <a:avLst/>
@@ -7973,7 +7973,7 @@
                 </a:solidFill>
                 <a:latin typeface="Segoe UI"/>
               </a:rPr>
-              <a:t>Alle drie zaten ze deze zomer in dit project, en geen ervan was zichtbaar aan het scherm.</a:t>
+              <a:t>Alle drie zaten ze deze zomer in dit project.</a:t>
             </a:r>
           </a:p>
         </p:txBody>
@@ -8766,7 +8766,7 @@
                 </a:solidFill>
                 <a:latin typeface="Segoe UI"/>
               </a:rPr>
-              <a:t>En één toets die dit operationeel maakt: de verkeerd-doen-test in week 7.</a:t>
+              <a:t>Toets ze met de verkeerd-doen-test in week 7.</a:t>
             </a:r>
           </a:p>
         </p:txBody>
@@ -9114,7 +9114,7 @@
                 </a:solidFill>
                 <a:latin typeface="Segoe UI"/>
               </a:rPr>
-              <a:t>Elk formulier en elk toestel, met alleen de werkinstructie erbij. Kijk toe en zeg niets. Waar hij aarzelt of het verkeerd invult, is het ontwerp fout — niet de collega.</a:t>
+              <a:t>Elk formulier en elk toestel, met alleen de werkinstructie erbij. Kijk toe en zeg niets. Waar hij aarzelt, is het ontwerp fout.</a:t>
             </a:r>
           </a:p>
         </p:txBody>
@@ -9240,7 +9240,7 @@
                 </a:solidFill>
                 <a:latin typeface="Segoe UI"/>
               </a:rPr>
-              <a:t>Een halve dag werk. Vangt meer dan een week nalezen, omdat u ziet wat u zelf niet meer kunt zien.</a:t>
+              <a:t>Een halve dag werk, en het vangt meer dan een week nalezen.</a:t>
             </a:r>
           </a:p>
         </p:txBody>
@@ -11841,7 +11841,7 @@
                 </a:solidFill>
                 <a:latin typeface="Segoe UI"/>
               </a:rPr>
-              <a:t>Acht punten. Wat op 1 december nog openstaat, wordt in februari een protocolafwijking op een patiënt.</a:t>
+              <a:t>Wat op 1 december openstaat, wordt in februari een protocolafwijking op een patiënt.</a:t>
             </a:r>
           </a:p>
         </p:txBody>
@@ -13861,7 +13861,7 @@
         <p:spPr>
           <a:xfrm>
             <a:off x="634984" y="4990975"/>
-            <a:ext cx="10921726" cy="1161868"/>
+            <a:ext cx="10921726" cy="771429"/>
           </a:xfrm>
           <a:prstGeom prst="roundRect">
             <a:avLst>
@@ -13909,7 +13909,7 @@
         <p:spPr>
           <a:xfrm>
             <a:off x="952476" y="5156071"/>
-            <a:ext cx="10286742" cy="907874"/>
+            <a:ext cx="10286742" cy="517435"/>
           </a:xfrm>
           <a:prstGeom prst="rect">
             <a:avLst/>
@@ -13934,7 +13934,7 @@
                 </a:solidFill>
                 <a:latin typeface="Segoe UI"/>
               </a:rPr>
-              <a:t>Oktober is de zwaarste maand, en het meeste ervan is ontwerpwerk. Wie daar uitloopt, loopt in november uit op de opleiding.</a:t>
+              <a:t>Oktober is de zwaarste maand. Februari verschuift niet.</a:t>
             </a:r>
           </a:p>
         </p:txBody>
@@ -15086,8 +15086,8 @@
         </p:nvSpPr>
         <p:spPr>
           <a:xfrm>
-            <a:off x="634984" y="4992194"/>
-            <a:ext cx="10921726" cy="1116352"/>
+            <a:off x="634984" y="5371965"/>
+            <a:ext cx="10921726" cy="736581"/>
           </a:xfrm>
           <a:prstGeom prst="roundRect">
             <a:avLst>
@@ -15134,8 +15134,8 @@
         </p:nvSpPr>
         <p:spPr>
           <a:xfrm>
-            <a:off x="952476" y="5169989"/>
-            <a:ext cx="10286742" cy="760761"/>
+            <a:off x="952476" y="5549761"/>
+            <a:ext cx="10286742" cy="380990"/>
           </a:xfrm>
           <a:prstGeom prst="rect">
             <a:avLst/>
@@ -15160,7 +15160,7 @@
                 </a:solidFill>
                 <a:latin typeface="Segoe UI"/>
               </a:rPr>
-              <a:t>Vier dingen, en geen ervan kan wachten tot oktober: alles wat daarna komt bouwt hierop voort.</a:t>
+              <a:t>Alles in oktober bouwt op deze vier voort.</a:t>
             </a:r>
           </a:p>
         </p:txBody>
@@ -17111,8 +17111,8 @@
         </p:nvSpPr>
         <p:spPr>
           <a:xfrm>
-            <a:off x="634984" y="4992194"/>
-            <a:ext cx="10921726" cy="1116352"/>
+            <a:off x="634984" y="5371965"/>
+            <a:ext cx="10921726" cy="736581"/>
           </a:xfrm>
           <a:prstGeom prst="roundRect">
             <a:avLst>
@@ -17159,8 +17159,8 @@
         </p:nvSpPr>
         <p:spPr>
           <a:xfrm>
-            <a:off x="952476" y="5169989"/>
-            <a:ext cx="10286742" cy="760761"/>
+            <a:off x="952476" y="5549761"/>
+            <a:ext cx="10286742" cy="380990"/>
           </a:xfrm>
           <a:prstGeom prst="rect">
             <a:avLst/>
@@ -17185,7 +17185,7 @@
                 </a:solidFill>
                 <a:latin typeface="Segoe UI"/>
               </a:rPr>
-              <a:t>Plus het materiaalontwerp, de protocolpaper, en de afnameschema’s van Koen en Maaike voor de economische analyse en de procesevaluatie.</a:t>
+              <a:t>Plus materiaalontwerp, de protocolpaper, en de afnameschema’s van Koen en Maaike.</a:t>
             </a:r>
           </a:p>
         </p:txBody>
@@ -18065,8 +18065,8 @@
         </p:nvSpPr>
         <p:spPr>
           <a:xfrm>
-            <a:off x="634984" y="4992194"/>
-            <a:ext cx="10921726" cy="1116352"/>
+            <a:off x="634984" y="5371965"/>
+            <a:ext cx="10921726" cy="736581"/>
           </a:xfrm>
           <a:prstGeom prst="roundRect">
             <a:avLst>
@@ -18113,8 +18113,8 @@
         </p:nvSpPr>
         <p:spPr>
           <a:xfrm>
-            <a:off x="952476" y="5169989"/>
-            <a:ext cx="10286742" cy="760761"/>
+            <a:off x="952476" y="5549761"/>
+            <a:ext cx="10286742" cy="380990"/>
           </a:xfrm>
           <a:prstGeom prst="rect">
             <a:avLst/>
@@ -18139,7 +18139,7 @@
                 </a:solidFill>
                 <a:latin typeface="Segoe UI"/>
               </a:rPr>
-              <a:t>Eén ontwerpstramien voor alles wat de patiënt meekrijgt. Wie drie folders krijgt die er verschillend uitzien, leest er één.</a:t>
+              <a:t>Eén ontwerpstramien voor alles wat de patiënt meekrijgt.</a:t>
             </a:r>
           </a:p>
         </p:txBody>

</xml_diff>